<commit_message>
Restauracion de la primera version
</commit_message>
<xml_diff>
--- a/clas.pptx
+++ b/clas.pptx
@@ -4894,42 +4894,6 @@
           <a:chExt cx="0" cy="0"/>
         </a:xfrm>
       </p:grpSpPr>
-      <p:sp>
-        <p:nvSpPr>
-          <p:cNvPr id="2" name="CuadroTexto 1">
-            <a:extLst>
-              <a:ext uri="{FF2B5EF4-FFF2-40B4-BE49-F238E27FC236}">
-                <a16:creationId xmlns:a16="http://schemas.microsoft.com/office/drawing/2014/main" id="{4B57E071-E3F6-4B2B-97F2-2E5101282BF6}"/>
-              </a:ext>
-            </a:extLst>
-          </p:cNvPr>
-          <p:cNvSpPr txBox="1"/>
-          <p:nvPr/>
-        </p:nvSpPr>
-        <p:spPr>
-          <a:xfrm>
-            <a:off x="1914525" y="2438400"/>
-            <a:ext cx="9001125" cy="1323439"/>
-          </a:xfrm>
-          <a:prstGeom prst="rect">
-            <a:avLst/>
-          </a:prstGeom>
-          <a:noFill/>
-        </p:spPr>
-        <p:txBody>
-          <a:bodyPr wrap="square" rtlCol="0">
-            <a:spAutoFit/>
-          </a:bodyPr>
-          <a:lstStyle/>
-          <a:p>
-            <a:r>
-              <a:rPr lang="es-PE" sz="8000" dirty="0" err="1"/>
-              <a:t>freñlgkjjnrevcmsrmf</a:t>
-            </a:r>
-            <a:endParaRPr lang="es-PE" sz="8000" dirty="0"/>
-          </a:p>
-        </p:txBody>
-      </p:sp>
     </p:spTree>
     <p:extLst>
       <p:ext uri="{BB962C8B-B14F-4D97-AF65-F5344CB8AC3E}">

</xml_diff>